<commit_message>
Simplify appendix title slide
</commit_message>
<xml_diff>
--- a/docs/strategy/ges2-service-cx-appendix.pptx
+++ b/docs/strategy/ges2-service-cx-appendix.pptx
@@ -1661,7 +1661,7 @@
         <p:spPr>
           <a:xfrm>
             <a:off x="640080" y="2011680"/>
-            <a:ext cx="9601200" cy="1737360"/>
+            <a:ext cx="9601200" cy="914400"/>
           </a:xfrm>
           <a:prstGeom prst="rect">
             <a:avLst/>
@@ -1688,74 +1688,15 @@
                 <a:ea typeface="Arial" pitchFamily="34" charset="-122"/>
                 <a:cs typeface="Arial" pitchFamily="34" charset="-120"/>
               </a:rPr>
-              <a:t>Приложение.</a:t>
+              <a:t>Приложение</a:t>
             </a:r>
             <a:endParaRPr lang="en-US" sz="3800" dirty="0"/>
           </a:p>
-          <a:p>
-            <a:pPr indent="0" marL="0">
-              <a:lnSpc>
-                <a:spcPct val="110000"/>
-              </a:lnSpc>
-              <a:buNone/>
-            </a:pPr>
-            <a:r>
-              <a:rPr lang="en-US" sz="3800" spc="76" kern="0" dirty="0">
-                <a:solidFill>
-                  <a:srgbClr val="000000"/>
-                </a:solidFill>
-                <a:latin typeface="Arial" pitchFamily="34" charset="0"/>
-                <a:ea typeface="Arial" pitchFamily="34" charset="-122"/>
-                <a:cs typeface="Arial" pitchFamily="34" charset="-120"/>
-              </a:rPr>
-              <a:t>Полный список тезисов</a:t>
-            </a:r>
-            <a:endParaRPr lang="en-US" sz="3800" dirty="0"/>
-          </a:p>
-        </p:txBody>
-      </p:sp>
-      <p:sp>
-        <p:nvSpPr>
-          <p:cNvPr id="4" name="Text 2"/>
-          <p:cNvSpPr txBox="1"/>
-          <p:nvPr/>
-        </p:nvSpPr>
-        <p:spPr>
-          <a:xfrm>
-            <a:off x="640080" y="3977640"/>
-            <a:ext cx="9144000" cy="365760"/>
-          </a:xfrm>
-          <a:prstGeom prst="rect">
-            <a:avLst/>
-          </a:prstGeom>
-          <a:noFill/>
-          <a:ln/>
-        </p:spPr>
-        <p:txBody>
-          <a:bodyPr wrap="square" lIns="0" tIns="0" rIns="0" bIns="0" rtlCol="0" anchor="ctr"/>
-          <a:lstStyle/>
-          <a:p>
-            <a:pPr indent="0" marL="0">
-              <a:buNone/>
-            </a:pPr>
-            <a:r>
-              <a:rPr lang="en-US" sz="1500" dirty="0">
-                <a:solidFill>
-                  <a:srgbClr val="000000"/>
-                </a:solidFill>
-                <a:latin typeface="Arial" pitchFamily="34" charset="0"/>
-                <a:ea typeface="Arial" pitchFamily="34" charset="-122"/>
-                <a:cs typeface="Arial" pitchFamily="34" charset="-120"/>
-              </a:rPr>
-              <a:t>К презентации «Предложение по улучшению направления сервиса и клиентского опыта ГЭС-2»</a:t>
-            </a:r>
-            <a:endParaRPr lang="en-US" sz="1500" dirty="0"/>
-          </a:p>
-        </p:txBody>
-      </p:sp>
-      <p:sp>
-        <p:nvSpPr>
-          <p:cNvPr id="5" name="Shape 3"/>
+        </p:txBody>
+      </p:sp>
+      <p:sp>
+        <p:nvSpPr>
+          <p:cNvPr id="4" name="Shape 2"/>
           <p:cNvSpPr/>
           <p:nvPr/>
         </p:nvSpPr>
@@ -1778,7 +1719,7 @@
       </p:sp>
       <p:sp>
         <p:nvSpPr>
-          <p:cNvPr id="6" name="Text 4"/>
+          <p:cNvPr id="5" name="Text 3"/>
           <p:cNvSpPr txBox="1"/>
           <p:nvPr/>
         </p:nvSpPr>
@@ -1817,7 +1758,7 @@
       </p:sp>
       <p:sp>
         <p:nvSpPr>
-          <p:cNvPr id="7" name="Text 5"/>
+          <p:cNvPr id="6" name="Text 4"/>
           <p:cNvSpPr txBox="1"/>
           <p:nvPr/>
         </p:nvSpPr>

</xml_diff>

<commit_message>
Drop count line from appendix title slide
</commit_message>
<xml_diff>
--- a/docs/strategy/ges2-service-cx-appendix.pptx
+++ b/docs/strategy/ges2-service-cx-appendix.pptx
@@ -1660,7 +1660,7 @@
         </p:nvSpPr>
         <p:spPr>
           <a:xfrm>
-            <a:off x="640080" y="2011680"/>
+            <a:off x="640080" y="2880360"/>
             <a:ext cx="9601200" cy="914400"/>
           </a:xfrm>
           <a:prstGeom prst="rect">
@@ -1696,69 +1696,7 @@
       </p:sp>
       <p:sp>
         <p:nvSpPr>
-          <p:cNvPr id="4" name="Shape 2"/>
-          <p:cNvSpPr/>
-          <p:nvPr/>
-        </p:nvSpPr>
-        <p:spPr>
-          <a:xfrm>
-            <a:off x="640080" y="4663440"/>
-            <a:ext cx="10911535" cy="0"/>
-          </a:xfrm>
-          <a:prstGeom prst="line">
-            <a:avLst/>
-          </a:prstGeom>
-          <a:noFill/>
-          <a:ln w="9525">
-            <a:solidFill>
-              <a:srgbClr val="EEEEEE"/>
-            </a:solidFill>
-            <a:prstDash val="solid"/>
-          </a:ln>
-        </p:spPr>
-      </p:sp>
-      <p:sp>
-        <p:nvSpPr>
-          <p:cNvPr id="5" name="Text 3"/>
-          <p:cNvSpPr txBox="1"/>
-          <p:nvPr/>
-        </p:nvSpPr>
-        <p:spPr>
-          <a:xfrm>
-            <a:off x="640080" y="4846320"/>
-            <a:ext cx="7315200" cy="320040"/>
-          </a:xfrm>
-          <a:prstGeom prst="rect">
-            <a:avLst/>
-          </a:prstGeom>
-          <a:noFill/>
-          <a:ln/>
-        </p:spPr>
-        <p:txBody>
-          <a:bodyPr wrap="square" lIns="0" tIns="0" rIns="0" bIns="0" rtlCol="0" anchor="ctr"/>
-          <a:lstStyle/>
-          <a:p>
-            <a:pPr indent="0" marL="0">
-              <a:buNone/>
-            </a:pPr>
-            <a:r>
-              <a:rPr lang="en-US" sz="1500" dirty="0">
-                <a:solidFill>
-                  <a:srgbClr val="000000"/>
-                </a:solidFill>
-                <a:latin typeface="Arial" pitchFamily="34" charset="0"/>
-                <a:ea typeface="Arial" pitchFamily="34" charset="-122"/>
-                <a:cs typeface="Arial" pitchFamily="34" charset="-120"/>
-              </a:rPr>
-              <a:t>48 пунктов в восьми группах</a:t>
-            </a:r>
-            <a:endParaRPr lang="en-US" sz="1500" dirty="0"/>
-          </a:p>
-        </p:txBody>
-      </p:sp>
-      <p:sp>
-        <p:nvSpPr>
-          <p:cNvPr id="6" name="Text 4"/>
+          <p:cNvPr id="4" name="Text 2"/>
           <p:cNvSpPr txBox="1"/>
           <p:nvPr/>
         </p:nvSpPr>

</xml_diff>

<commit_message>
Align mystery visit frequency across appendix and theses
</commit_message>
<xml_diff>
--- a/docs/strategy/ges2-service-cx-appendix.pptx
+++ b/docs/strategy/ges2-service-cx-appendix.pptx
@@ -3108,7 +3108,7 @@
         <p:spPr>
           <a:xfrm>
             <a:off x="1207008" y="4526280"/>
-            <a:ext cx="10058400" cy="338328"/>
+            <a:ext cx="10058400" cy="603504"/>
           </a:xfrm>
           <a:prstGeom prst="rect">
             <a:avLst/>
@@ -3135,7 +3135,7 @@
                 <a:ea typeface="Arial" pitchFamily="34" charset="-122"/>
                 <a:cs typeface="Arial" pitchFamily="34" charset="-120"/>
               </a:rPr>
-              <a:t>Введение годового цикла независимых тайных визитов по всей цепочке - от сайта до кафе/магазина и выхода.</a:t>
+              <a:t>Введение практики независимых тайных визитов несколько раз в год по всей цепочке - от сайта до кафе/магазина и выхода.</a:t>
             </a:r>
             <a:endParaRPr lang="en-US" sz="1400" dirty="0"/>
           </a:p>
@@ -3149,7 +3149,7 @@
         </p:nvSpPr>
         <p:spPr>
           <a:xfrm>
-            <a:off x="640080" y="4901184"/>
+            <a:off x="640080" y="5166360"/>
             <a:ext cx="10911535" cy="0"/>
           </a:xfrm>
           <a:prstGeom prst="line">
@@ -3172,7 +3172,7 @@
         </p:nvSpPr>
         <p:spPr>
           <a:xfrm>
-            <a:off x="640080" y="4992624"/>
+            <a:off x="640080" y="5257800"/>
             <a:ext cx="502920" cy="274320"/>
           </a:xfrm>
           <a:prstGeom prst="rect">
@@ -3211,7 +3211,7 @@
         </p:nvSpPr>
         <p:spPr>
           <a:xfrm>
-            <a:off x="1207008" y="4974336"/>
+            <a:off x="1207008" y="5239512"/>
             <a:ext cx="10058400" cy="603504"/>
           </a:xfrm>
           <a:prstGeom prst="rect">

</xml_diff>